<commit_message>
docs: link the new demo video with the technical deep-dive
Point the README, docs site, PyPI description, project URLs and the deck's
link and QR code at https://youtu.be/nhXP6QLFjoU. The deck's GitHub link and
QR now point at the repository instead of the merged feature branch, and the
test count reads 1,002 everywhere.
</commit_message>
<xml_diff>
--- a/docs/Q-Day_Time_Machine_VTU-QFF-HC-0106.pptx
+++ b/docs/Q-Day_Time_Machine_VTU-QFF-HC-0106.pptx
@@ -4743,33 +4743,9 @@
           <a:p>
             <a:r>
               <a:rPr lang="en-IN" sz="900" dirty="0">
-                <a:hlinkClick r:id="rId3"/>
-              </a:rPr>
-              <a:t>vtu-qiskit-fall-fest-2026/</a:t>
-            </a:r>
-            <a:r>
-              <a:rPr lang="en-IN" sz="900" dirty="0" err="1">
-                <a:hlinkClick r:id="rId3"/>
-              </a:rPr>
-              <a:t>vtu</a:t>
-            </a:r>
-            <a:r>
-              <a:rPr lang="en-IN" sz="900" dirty="0">
-                <a:hlinkClick r:id="rId3"/>
-              </a:rPr>
-              <a:t>-</a:t>
-            </a:r>
-            <a:r>
-              <a:rPr lang="en-IN" sz="900" dirty="0" err="1">
-                <a:hlinkClick r:id="rId3"/>
-              </a:rPr>
-              <a:t>hc</a:t>
-            </a:r>
-            <a:r>
-              <a:rPr lang="en-IN" sz="900" dirty="0">
-                <a:hlinkClick r:id="rId3"/>
-              </a:rPr>
-              <a:t>-straw-hat-pirates at feature/q-day-time-machine</a:t>
+                <a:hlinkClick r:id="rId8"/>
+              </a:rPr>
+              <a:t>vtu-qiskit-fall-fest-2026/vtu-hc-straw-hat-pirates</a:t>
             </a:r>
             <a:endParaRPr lang="en-US" sz="900" dirty="0"/>
           </a:p>
@@ -4823,9 +4799,9 @@
           <a:p>
             <a:r>
               <a:rPr lang="en-US" sz="900" dirty="0">
-                <a:hlinkClick r:id="rId8"/>
-              </a:rPr>
-              <a:t>https://youtu.be/8AHgcPisYlE</a:t>
+                <a:hlinkClick r:id="rId9"/>
+              </a:rPr>
+              <a:t>https://youtu.be/nhXP6QLFjoU</a:t>
             </a:r>
           </a:p>
         </p:txBody>
@@ -4935,7 +4911,7 @@
           <p:nvPr/>
         </p:nvPicPr>
         <p:blipFill>
-          <a:blip r:embed="rId9"/>
+          <a:blip r:embed="rId3"/>
           <a:stretch>
             <a:fillRect/>
           </a:stretch>
@@ -11754,7 +11730,7 @@
                 </a:solidFill>
                 <a:latin typeface="Georgia"/>
               </a:rPr>
-              <a:t>998</a:t>
+              <a:t>1,002</a:t>
             </a:r>
           </a:p>
         </p:txBody>

</xml_diff>

<commit_message>
docs: add the live app link and QR code to the deck's closing slide
Slide 10 now has three matching link cards and QR codes: GitHub, the demo
video and https://qdaytimemachine.vercel.app. The globe is smaller and higher
to make room.
</commit_message>
<xml_diff>
--- a/docs/Q-Day_Time_Machine_VTU-QFF-HC-0106.pptx
+++ b/docs/Q-Day_Time_Machine_VTU-QFF-HC-0106.pptx
@@ -4806,6 +4806,61 @@
           </a:p>
         </p:txBody>
       </p:sp>
+      <p:sp>
+        <p:nvSpPr>
+          <p:cNvPr id="6" name="Field: LIVE APP"/>
+          <p:cNvSpPr/>
+          <p:nvPr/>
+        </p:nvSpPr>
+        <p:spPr>
+          <a:xfrm>
+            <a:off x="5239512" y="3154680"/>
+            <a:ext cx="2286000" cy="731521"/>
+          </a:xfrm>
+          <a:prstGeom prst="roundRect">
+            <a:avLst>
+              <a:gd name="adj" fmla="val 10345"/>
+            </a:avLst>
+          </a:prstGeom>
+          <a:solidFill>
+            <a:srgbClr val="FFFFFF"/>
+          </a:solidFill>
+          <a:ln w="9525">
+            <a:solidFill>
+              <a:srgbClr val="B8BDEB"/>
+            </a:solidFill>
+          </a:ln>
+        </p:spPr>
+        <p:txBody>
+          <a:bodyPr wrap="square" lIns="63500" tIns="114300" rIns="114300" bIns="38100" rtlCol="0" anchor="t"/>
+          <a:lstStyle/>
+          <a:p>
+            <a:pPr marL="0" indent="0" algn="l">
+              <a:buNone/>
+            </a:pPr>
+            <a:r>
+              <a:rPr lang="en-US" sz="900" b="1" kern="0" spc="100" dirty="0">
+                <a:solidFill>
+                  <a:srgbClr val="5B3BA8"/>
+                </a:solidFill>
+                <a:latin typeface="Calibri" pitchFamily="34" charset="0"/>
+                <a:ea typeface="Calibri" pitchFamily="34" charset="-122"/>
+                <a:cs typeface="Calibri" pitchFamily="34" charset="-120"/>
+              </a:rPr>
+              <a:t>LIVE APP</a:t>
+            </a:r>
+            <a:endParaRPr lang="en-US" sz="900" dirty="0"/>
+          </a:p>
+          <a:p>
+            <a:r>
+              <a:rPr lang="en-US" sz="900" dirty="0">
+                <a:hlinkClick r:id="rId3"/>
+              </a:rPr>
+              <a:t>https://qdaytimemachine.vercel.app</a:t>
+            </a:r>
+          </a:p>
+        </p:txBody>
+      </p:sp>
       <p:pic>
         <p:nvPicPr>
           <p:cNvPr id="7" name="Bloch sphere ring" descr="sphere.png"/>
@@ -4822,8 +4877,8 @@
         </p:blipFill>
         <p:spPr>
           <a:xfrm>
-            <a:off x="5440680" y="1188720"/>
-            <a:ext cx="3200400" cy="3200400"/>
+            <a:off x="5989320" y="896112"/>
+            <a:ext cx="2103120" cy="2103120"/>
           </a:xfrm>
           <a:prstGeom prst="rect">
             <a:avLst/>
@@ -4870,7 +4925,7 @@
         </p:blipFill>
         <p:spPr>
           <a:xfrm>
-            <a:off x="4754880" y="3840480"/>
+            <a:off x="7818120" y="2788920"/>
             <a:ext cx="548640" cy="329184"/>
           </a:xfrm>
           <a:prstGeom prst="rect">
@@ -4911,7 +4966,7 @@
           <p:nvPr/>
         </p:nvPicPr>
         <p:blipFill>
-          <a:blip r:embed="rId3"/>
+          <a:blip r:embed="rId10"/>
           <a:stretch>
             <a:fillRect/>
           </a:stretch>
@@ -4990,7 +5045,7 @@
           <p:nvPr/>
         </p:nvPicPr>
         <p:blipFill>
-          <a:blip r:embed="rId10"/>
+          <a:blip r:embed="rId11"/>
           <a:stretch>
             <a:fillRect/>
           </a:stretch>
@@ -5056,6 +5111,85 @@
                 <a:latin typeface="Calibri"/>
               </a:rPr>
               <a:t>Demo on YouTube</a:t>
+            </a:r>
+          </a:p>
+        </p:txBody>
+      </p:sp>
+      <p:pic>
+        <p:nvPicPr>
+          <p:cNvPr id="15" name="QR Live app" descr="QR code linking to the live app"/>
+          <p:cNvPicPr>
+            <a:picLocks noChangeAspect="1"/>
+          </p:cNvPicPr>
+          <p:nvPr/>
+        </p:nvPicPr>
+        <p:blipFill>
+          <a:blip r:embed="rId12"/>
+          <a:stretch>
+            <a:fillRect/>
+          </a:stretch>
+        </p:blipFill>
+        <p:spPr>
+          <a:xfrm>
+            <a:off x="5257800" y="3931920"/>
+            <a:ext cx="548640" cy="548640"/>
+          </a:xfrm>
+          <a:prstGeom prst="rect">
+            <a:avLst/>
+          </a:prstGeom>
+        </p:spPr>
+      </p:pic>
+      <p:sp>
+        <p:nvSpPr>
+          <p:cNvPr id="16" name="Text"/>
+          <p:cNvSpPr txBox="1"/>
+          <p:nvPr/>
+        </p:nvSpPr>
+        <p:spPr>
+          <a:xfrm>
+            <a:off x="5897880" y="3995928"/>
+            <a:ext cx="1463040" cy="420624"/>
+          </a:xfrm>
+          <a:prstGeom prst="rect">
+            <a:avLst/>
+          </a:prstGeom>
+          <a:noFill/>
+        </p:spPr>
+        <p:txBody>
+          <a:bodyPr wrap="square" anchor="ctr" lIns="0" rIns="0" tIns="0" bIns="0">
+            <a:spAutoFit/>
+          </a:bodyPr>
+          <a:lstStyle/>
+          <a:p>
+            <a:pPr algn="l">
+              <a:spcAft>
+                <a:spcPts val="200"/>
+              </a:spcAft>
+            </a:pPr>
+            <a:r>
+              <a:rPr sz="950" b="0" i="0">
+                <a:solidFill>
+                  <a:srgbClr val="6B5E8A"/>
+                </a:solidFill>
+                <a:latin typeface="Calibri"/>
+              </a:rPr>
+              <a:t>Scan for</a:t>
+            </a:r>
+          </a:p>
+          <a:p>
+            <a:pPr algn="l">
+              <a:spcAft>
+                <a:spcPts val="200"/>
+              </a:spcAft>
+            </a:pPr>
+            <a:r>
+              <a:rPr sz="1100" b="1" i="0">
+                <a:solidFill>
+                  <a:srgbClr val="2E1B5B"/>
+                </a:solidFill>
+                <a:latin typeface="Calibri"/>
+              </a:rPr>
+              <a:t>Live app</a:t>
             </a:r>
           </a:p>
         </p:txBody>

</xml_diff>